<commit_message>
Add initial setup files and resources for Leitura Bíblica application
- Added executable file for Leitura Bíblica.
- Included application icon (icon.ico).
- Created Inno Setup script (script.iss) for installation, including app details, file paths, and desktop shortcut options.
</commit_message>
<xml_diff>
--- a/modelo.pptx
+++ b/modelo.pptx
@@ -257,8 +257,11 @@
     </a:lvl9pPr>
   </p:defaultTextStyle>
   <p:extLst>
+    <p:ext uri="{EFAFB233-063F-42B5-8137-9DF3F51BA10A}">
+      <p15:sldGuideLst xmlns:p15="http://schemas.microsoft.com/office/powerpoint/2012/main"/>
+    </p:ext>
     <p:ext uri="GoogleSlidesCustomDataVersion2">
-      <go:slidesCustomData xmlns:go="http://customooxmlschemas.google.com/" xmlns:ahyp="http://schemas.microsoft.com/office/drawing/2018/hyperlinkcolor" xmlns:p15="http://schemas.microsoft.com/office/powerpoint/2012/main" xmlns:p14="http://schemas.microsoft.com/office/powerpoint/2010/main" xmlns:com="http://schemas.openxmlformats.org/drawingml/2006/compatibility" xmlns:pvml="urn:schemas-microsoft-com:office:powerpoint" xmlns:v="urn:schemas-microsoft-com:vml" xmlns:o="urn:schemas-microsoft-com:office:office" xmlns:dgm="http://schemas.openxmlformats.org/drawingml/2006/diagram" xmlns:c="http://schemas.openxmlformats.org/drawingml/2006/chart" xmlns:mv="urn:schemas-microsoft-com:mac:vml" xmlns:mc="http://schemas.openxmlformats.org/markup-compatibility/2006" xmlns="" r:id="rId20" roundtripDataSignature="AMtx7mjPg21VtvQxII046SqB4urLoOaiKQ=="/>
+      <go:slidesCustomData xmlns="" xmlns:mc="http://schemas.openxmlformats.org/markup-compatibility/2006" xmlns:mv="urn:schemas-microsoft-com:mac:vml" xmlns:c="http://schemas.openxmlformats.org/drawingml/2006/chart" xmlns:dgm="http://schemas.openxmlformats.org/drawingml/2006/diagram" xmlns:o="urn:schemas-microsoft-com:office:office" xmlns:v="urn:schemas-microsoft-com:vml" xmlns:pvml="urn:schemas-microsoft-com:office:powerpoint" xmlns:com="http://schemas.openxmlformats.org/drawingml/2006/compatibility" xmlns:p14="http://schemas.microsoft.com/office/powerpoint/2010/main" xmlns:p15="http://schemas.microsoft.com/office/powerpoint/2012/main" xmlns:ahyp="http://schemas.microsoft.com/office/drawing/2018/hyperlinkcolor" xmlns:go="http://customooxmlschemas.google.com/" r:id="rId20" roundtripDataSignature="AMtx7mjPg21VtvQxII046SqB4urLoOaiKQ=="/>
     </p:ext>
   </p:extLst>
 </p:presentation>
@@ -14651,8 +14654,8 @@
         </p:nvSpPr>
         <p:spPr>
           <a:xfrm>
-            <a:off x="2345787" y="1797784"/>
-            <a:ext cx="7500300" cy="1631175"/>
+            <a:off x="0" y="1793814"/>
+            <a:ext cx="12192000" cy="1631175"/>
           </a:xfrm>
           <a:prstGeom prst="rect">
             <a:avLst/>

</xml_diff>